<commit_message>
1.16 fix PPT desktop alignment: valid cells, deflate zip
</commit_message>
<xml_diff>
--- a/timesheet/daka-template.pptx
+++ b/timesheet/daka-template.pptx
@@ -3161,7 +3161,7 @@
                         <a:buNone/>
                       </a:pPr>
                       <a:r>
-                        <a:rPr lang="en-US" sz="1100" b="0" i="0" u="none" strike="noStrike" kern="1200">
+                        <a:rPr lang="en-US" sz="1100" b="0" i="0" u="none" strike="noStrike" kern="1200" dirty="0">
                           <a:solidFill>
                             <a:srgbClr val="000000"/>
                           </a:solidFill>
@@ -3489,7 +3489,7 @@
                         <a:buNone/>
                       </a:pPr>
                       <a:r>
-                        <a:rPr lang="en-US" sz="1100" b="0" i="0" u="none" strike="noStrike" kern="1200">
+                        <a:rPr lang="en-US" sz="1100" b="0" i="0" u="none" strike="noStrike" kern="1200" dirty="0">
                           <a:solidFill>
                             <a:srgbClr val="000000"/>
                           </a:solidFill>
@@ -3557,7 +3557,7 @@
                         <a:buNone/>
                       </a:pPr>
                       <a:r>
-                        <a:rPr lang="en-US" sz="1100" b="0" i="0" u="none" strike="noStrike" kern="1200">
+                        <a:rPr lang="en-US" sz="1100" b="0" i="0" u="none" strike="noStrike" kern="1200" dirty="0">
                           <a:solidFill>
                             <a:srgbClr val="000000"/>
                           </a:solidFill>
@@ -3618,7 +3618,7 @@
                         <a:buNone/>
                       </a:pPr>
                       <a:r>
-                        <a:rPr lang="en-US" sz="1100" b="0" i="0" u="none" strike="noStrike" kern="1200">
+                        <a:rPr lang="en-US" sz="1100" b="0" i="0" u="none" strike="noStrike" kern="1200" dirty="0">
                           <a:solidFill>
                             <a:srgbClr val="000000"/>
                           </a:solidFill>
@@ -3885,7 +3885,7 @@
                         <a:buNone/>
                       </a:pPr>
                       <a:r>
-                        <a:rPr lang="en-US" sz="1100" b="0" i="0" u="none" strike="noStrike" kern="1200">
+                        <a:rPr lang="en-US" sz="1100" b="0" i="0" u="none" strike="noStrike" kern="1200" dirty="0">
                           <a:solidFill>
                             <a:srgbClr val="000000"/>
                           </a:solidFill>
@@ -3946,7 +3946,7 @@
                         <a:buNone/>
                       </a:pPr>
                       <a:r>
-                        <a:rPr lang="en-US" sz="1100" b="0" i="0" u="none" strike="noStrike" kern="1200">
+                        <a:rPr lang="en-US" sz="1100" b="0" i="0" u="none" strike="noStrike" kern="1200" dirty="0">
                           <a:solidFill>
                             <a:srgbClr val="000000"/>
                           </a:solidFill>
@@ -4014,7 +4014,7 @@
                         <a:buNone/>
                       </a:pPr>
                       <a:r>
-                        <a:rPr lang="en-US" sz="1100" b="0" i="0" u="none" strike="noStrike" kern="1200">
+                        <a:rPr lang="en-US" sz="1100" b="0" i="0" u="none" strike="noStrike" kern="1200" dirty="0">
                           <a:solidFill>
                             <a:srgbClr val="000000"/>
                           </a:solidFill>
@@ -4084,7 +4084,7 @@
                         <a:buNone/>
                       </a:pPr>
                       <a:r>
-                        <a:rPr lang="en-US" sz="1100" b="0" i="0" u="none" strike="noStrike" kern="1200">
+                        <a:rPr lang="en-US" sz="1100" b="0" i="0" u="none" strike="noStrike" kern="1200" dirty="0">
                           <a:solidFill>
                             <a:srgbClr val="000000"/>
                           </a:solidFill>
@@ -4480,7 +4480,7 @@
                         <a:buNone/>
                       </a:pPr>
                       <a:r>
-                        <a:rPr lang="zh-MO" altLang="en-US" sz="1100" b="0" i="0" u="none" strike="noStrike" kern="1200" dirty="0">
+                        <a:rPr lang="en-US" sz="1100" b="0" i="0" u="none" strike="noStrike" kern="1200" dirty="0">
                           <a:solidFill>
                             <a:srgbClr val="000000"/>
                           </a:solidFill>
@@ -4490,18 +4490,6 @@
                           <a:cs typeface="+mn-cs"/>
                         </a:rPr>
                         <a:t>@@D04C0@@</a:t>
-                      </a:r>
-                      <a:r>
-                        <a:rPr lang="en-US" altLang="zh-MO" sz="1100" b="0" i="0" u="none" strike="noStrike" kern="1200" dirty="0">
-                          <a:solidFill>
-                            <a:srgbClr val="000000"/>
-                          </a:solidFill>
-                          <a:effectLst/>
-                          <a:latin typeface="Abadi" panose="020F0502020204030204" pitchFamily="34" charset="0"/>
-                          <a:ea typeface="+mn-ea"/>
-                          <a:cs typeface="+mn-cs"/>
-                        </a:rPr>
-                        <a:t/>
                       </a:r>
                       <a:endParaRPr lang="zh-MO" altLang="en-US" sz="1100" b="0" i="0" u="none" strike="noStrike" kern="1200" dirty="0">
                         <a:solidFill>
@@ -4908,7 +4896,7 @@
                         <a:buNone/>
                       </a:pPr>
                       <a:r>
-                        <a:rPr lang="zh-MO" altLang="en-US" sz="1100" b="0" i="0" u="none" strike="noStrike" kern="1200">
+                        <a:rPr lang="en-US" sz="1100" b="0" i="0" u="none" strike="noStrike" kern="1200" dirty="0">
                           <a:solidFill>
                             <a:srgbClr val="000000"/>
                           </a:solidFill>
@@ -5037,7 +5025,7 @@
                         <a:buNone/>
                       </a:pPr>
                       <a:r>
-                        <a:rPr lang="en-US" sz="1100" b="0" i="0" u="none" strike="noStrike" kern="1200">
+                        <a:rPr lang="en-US" sz="1100" b="0" i="0" u="none" strike="noStrike" kern="1200" dirty="0">
                           <a:solidFill>
                             <a:srgbClr val="000000"/>
                           </a:solidFill>
@@ -5366,7 +5354,7 @@
                         <a:buNone/>
                       </a:pPr>
                       <a:r>
-                        <a:rPr lang="en-US" sz="1100" b="0" i="0" u="none" strike="noStrike" kern="1200">
+                        <a:rPr lang="en-US" sz="1100" b="0" i="0" u="none" strike="noStrike" kern="1200" dirty="0">
                           <a:solidFill>
                             <a:srgbClr val="000000"/>
                           </a:solidFill>
@@ -5495,7 +5483,7 @@
                         <a:buNone/>
                       </a:pPr>
                       <a:r>
-                        <a:rPr lang="en-US" sz="1100" b="0" i="0" u="none" strike="noStrike" kern="1200">
+                        <a:rPr lang="en-US" sz="1100" b="0" i="0" u="none" strike="noStrike" kern="1200" dirty="0">
                           <a:solidFill>
                             <a:srgbClr val="000000"/>
                           </a:solidFill>
@@ -5771,7 +5759,7 @@
                         <a:buNone/>
                       </a:pPr>
                       <a:r>
-                        <a:rPr lang="en-US" sz="1100" b="0" i="0" u="none" strike="noStrike" kern="1200">
+                        <a:rPr lang="en-US" sz="1100" b="0" i="0" u="none" strike="noStrike" kern="1200" dirty="0">
                           <a:solidFill>
                             <a:srgbClr val="000000"/>
                           </a:solidFill>
@@ -5832,7 +5820,7 @@
                         <a:buNone/>
                       </a:pPr>
                       <a:r>
-                        <a:rPr lang="en-US" sz="1100" b="0" i="0" u="none" strike="noStrike" kern="1200">
+                        <a:rPr lang="en-US" sz="1100" b="0" i="0" u="none" strike="noStrike" kern="1200" dirty="0">
                           <a:solidFill>
                             <a:srgbClr val="000000"/>
                           </a:solidFill>
@@ -5961,7 +5949,7 @@
                         <a:buNone/>
                       </a:pPr>
                       <a:r>
-                        <a:rPr lang="en-US" sz="1100" b="0" i="0" u="none" strike="noStrike" kern="1200">
+                        <a:rPr lang="en-US" sz="1100" b="0" i="0" u="none" strike="noStrike" kern="1200" dirty="0">
                           <a:solidFill>
                             <a:srgbClr val="000000"/>
                           </a:solidFill>
@@ -6228,7 +6216,7 @@
                         <a:buNone/>
                       </a:pPr>
                       <a:r>
-                        <a:rPr lang="en-US" sz="1100" b="0" i="0" u="none" strike="noStrike" kern="1200">
+                        <a:rPr lang="en-US" sz="1100" b="0" i="0" u="none" strike="noStrike" kern="1200" dirty="0">
                           <a:solidFill>
                             <a:srgbClr val="000000"/>
                           </a:solidFill>
@@ -6289,7 +6277,7 @@
                         <a:buNone/>
                       </a:pPr>
                       <a:r>
-                        <a:rPr lang="en-US" sz="1100" b="0" i="0" u="none" strike="noStrike" kern="1200">
+                        <a:rPr lang="en-US" sz="1100" b="0" i="0" u="none" strike="noStrike" kern="1200" dirty="0">
                           <a:solidFill>
                             <a:srgbClr val="000000"/>
                           </a:solidFill>
@@ -6418,7 +6406,7 @@
                         <a:buNone/>
                       </a:pPr>
                       <a:r>
-                        <a:rPr lang="en-US" sz="1100" b="0" i="0" u="none" strike="noStrike" kern="1200">
+                        <a:rPr lang="en-US" sz="1100" b="0" i="0" u="none" strike="noStrike" kern="1200" dirty="0">
                           <a:solidFill>
                             <a:srgbClr val="000000"/>
                           </a:solidFill>
@@ -6685,7 +6673,7 @@
                         <a:buNone/>
                       </a:pPr>
                       <a:r>
-                        <a:rPr lang="en-US" sz="1100" b="0" i="0" u="none" strike="noStrike" kern="1200">
+                        <a:rPr lang="en-US" sz="1100" b="0" i="0" u="none" strike="noStrike" kern="1200" dirty="0">
                           <a:solidFill>
                             <a:srgbClr val="000000"/>
                           </a:solidFill>
@@ -6746,7 +6734,7 @@
                         <a:buNone/>
                       </a:pPr>
                       <a:r>
-                        <a:rPr lang="en-US" sz="1100" b="0" i="0" u="none" strike="noStrike" kern="1200">
+                        <a:rPr lang="en-US" sz="1100" b="0" i="0" u="none" strike="noStrike" kern="1200" dirty="0">
                           <a:solidFill>
                             <a:srgbClr val="000000"/>
                           </a:solidFill>
@@ -6875,7 +6863,7 @@
                         <a:buNone/>
                       </a:pPr>
                       <a:r>
-                        <a:rPr lang="en-US" sz="1100" b="0" i="0" u="none" strike="noStrike" kern="1200">
+                        <a:rPr lang="en-US" sz="1100" b="0" i="0" u="none" strike="noStrike" kern="1200" dirty="0">
                           <a:solidFill>
                             <a:srgbClr val="000000"/>
                           </a:solidFill>
@@ -7134,7 +7122,7 @@
                         <a:buNone/>
                       </a:pPr>
                       <a:r>
-                        <a:rPr lang="en-US" sz="1100" b="0" i="0" u="none" strike="noStrike" kern="1200">
+                        <a:rPr lang="en-US" sz="1100" b="0" i="0" u="none" strike="noStrike" kern="1200" dirty="0">
                           <a:solidFill>
                             <a:srgbClr val="000000"/>
                           </a:solidFill>
@@ -7195,7 +7183,7 @@
                         <a:buNone/>
                       </a:pPr>
                       <a:r>
-                        <a:rPr lang="en-US" sz="1100" b="0" i="0" u="none" strike="noStrike" kern="1200">
+                        <a:rPr lang="en-US" sz="1100" b="0" i="0" u="none" strike="noStrike" kern="1200" dirty="0">
                           <a:solidFill>
                             <a:srgbClr val="000000"/>
                           </a:solidFill>
@@ -7324,7 +7312,7 @@
                         <a:buNone/>
                       </a:pPr>
                       <a:r>
-                        <a:rPr lang="en-US" sz="1100" b="0" i="0" u="none" strike="noStrike" kern="1200">
+                        <a:rPr lang="en-US" sz="1100" b="0" i="0" u="none" strike="noStrike" kern="1200" dirty="0">
                           <a:solidFill>
                             <a:srgbClr val="000000"/>
                           </a:solidFill>
@@ -7591,7 +7579,7 @@
                         <a:buNone/>
                       </a:pPr>
                       <a:r>
-                        <a:rPr lang="en-US" sz="1100" b="0" i="0" u="none" strike="noStrike" kern="1200">
+                        <a:rPr lang="en-US" sz="1100" b="0" i="0" u="none" strike="noStrike" kern="1200" dirty="0">
                           <a:solidFill>
                             <a:srgbClr val="000000"/>
                           </a:solidFill>
@@ -7720,7 +7708,7 @@
                         <a:buNone/>
                       </a:pPr>
                       <a:r>
-                        <a:rPr lang="zh-MO" altLang="en-US" sz="1100" b="0" i="0" u="none" strike="noStrike" kern="1200" dirty="0">
+                        <a:rPr lang="en-US" sz="1100" b="0" i="0" u="none" strike="noStrike" kern="1200" dirty="0">
                           <a:solidFill>
                             <a:srgbClr val="000000"/>
                           </a:solidFill>
@@ -7730,18 +7718,6 @@
                           <a:cs typeface="+mn-cs"/>
                         </a:rPr>
                         <a:t>@@D11C0@@</a:t>
-                      </a:r>
-                      <a:r>
-                        <a:rPr lang="en-US" altLang="zh-MO" sz="1100" b="0" i="0" u="none" strike="noStrike" kern="1200" dirty="0">
-                          <a:solidFill>
-                            <a:srgbClr val="000000"/>
-                          </a:solidFill>
-                          <a:effectLst/>
-                          <a:latin typeface="Abadi" panose="020F0502020204030204" pitchFamily="34" charset="0"/>
-                          <a:ea typeface="+mn-ea"/>
-                          <a:cs typeface="+mn-cs"/>
-                        </a:rPr>
-                        <a:t/>
                       </a:r>
                       <a:endParaRPr lang="zh-MO" altLang="en-US" sz="1100" b="0" i="0" u="none" strike="noStrike" kern="1200" dirty="0">
                         <a:solidFill>
@@ -8148,7 +8124,7 @@
                         <a:buNone/>
                       </a:pPr>
                       <a:r>
-                        <a:rPr lang="zh-MO" altLang="en-US" sz="1100" b="0" i="0" u="none" strike="noStrike" kern="1200">
+                        <a:rPr lang="en-US" sz="1100" b="0" i="0" u="none" strike="noStrike" kern="1200" dirty="0">
                           <a:solidFill>
                             <a:srgbClr val="000000"/>
                           </a:solidFill>
@@ -8216,7 +8192,7 @@
                         <a:buNone/>
                       </a:pPr>
                       <a:r>
-                        <a:rPr lang="en-US" sz="1100" b="0" i="0" u="none" strike="noStrike" kern="1200">
+                        <a:rPr lang="en-US" sz="1100" b="0" i="0" u="none" strike="noStrike" kern="1200" dirty="0">
                           <a:solidFill>
                             <a:srgbClr val="000000"/>
                           </a:solidFill>
@@ -8536,7 +8512,7 @@
                         <a:buNone/>
                       </a:pPr>
                       <a:r>
-                        <a:rPr lang="en-US" sz="1100" b="0" i="0" u="none" strike="noStrike" kern="1200">
+                        <a:rPr lang="en-US" sz="1100" b="0" i="0" u="none" strike="noStrike" kern="1200" dirty="0">
                           <a:solidFill>
                             <a:srgbClr val="000000"/>
                           </a:solidFill>
@@ -8674,7 +8650,7 @@
                         <a:buNone/>
                       </a:pPr>
                       <a:r>
-                        <a:rPr lang="en-US" sz="1100" b="0" i="0" u="none" strike="noStrike" kern="1200">
+                        <a:rPr lang="en-US" sz="1100" b="0" i="0" u="none" strike="noStrike" kern="1200" dirty="0">
                           <a:solidFill>
                             <a:srgbClr val="000000"/>
                           </a:solidFill>
@@ -8994,7 +8970,7 @@
                         <a:buNone/>
                       </a:pPr>
                       <a:r>
-                        <a:rPr lang="en-US" sz="1100" b="0" i="0" u="none" strike="noStrike" kern="1200">
+                        <a:rPr lang="en-US" sz="1100" b="0" i="0" u="none" strike="noStrike" kern="1200" dirty="0">
                           <a:solidFill>
                             <a:srgbClr val="000000"/>
                           </a:solidFill>
@@ -9132,7 +9108,7 @@
                         <a:buNone/>
                       </a:pPr>
                       <a:r>
-                        <a:rPr lang="en-US" sz="1100" b="0" i="0" u="none" strike="noStrike" kern="1200">
+                        <a:rPr lang="en-US" sz="1100" b="0" i="0" u="none" strike="noStrike" kern="1200" dirty="0">
                           <a:solidFill>
                             <a:srgbClr val="000000"/>
                           </a:solidFill>
@@ -9452,7 +9428,7 @@
                         <a:buNone/>
                       </a:pPr>
                       <a:r>
-                        <a:rPr lang="en-US" sz="1100" b="0" i="0" u="none" strike="noStrike" kern="1200">
+                        <a:rPr lang="en-US" sz="1100" b="0" i="0" u="none" strike="noStrike" kern="1200" dirty="0">
                           <a:solidFill>
                             <a:srgbClr val="000000"/>
                           </a:solidFill>
@@ -9581,7 +9557,7 @@
                         <a:buNone/>
                       </a:pPr>
                       <a:r>
-                        <a:rPr lang="en-US" sz="1100" b="0" i="0" u="none" strike="noStrike" kern="1200">
+                        <a:rPr lang="en-US" sz="1100" b="0" i="0" u="none" strike="noStrike" kern="1200" dirty="0">
                           <a:solidFill>
                             <a:srgbClr val="000000"/>
                           </a:solidFill>
@@ -9901,7 +9877,7 @@
                         <a:buNone/>
                       </a:pPr>
                       <a:r>
-                        <a:rPr lang="en-US" sz="1100" b="0" i="0" u="none" strike="noStrike" kern="1200">
+                        <a:rPr lang="en-US" sz="1100" b="0" i="0" u="none" strike="noStrike" kern="1200" dirty="0">
                           <a:solidFill>
                             <a:srgbClr val="000000"/>
                           </a:solidFill>
@@ -10151,7 +10127,7 @@
                         <a:buNone/>
                       </a:pPr>
                       <a:r>
-                        <a:rPr lang="en-US" altLang="zh-MO" sz="1100" b="0" i="0" u="none" strike="noStrike" kern="1200" dirty="0">
+                        <a:rPr lang="en-US" sz="1100" b="0" i="0" u="none" strike="noStrike" kern="1200" dirty="0">
                           <a:solidFill>
                             <a:srgbClr val="000000"/>
                           </a:solidFill>
@@ -10212,7 +10188,7 @@
                         <a:buNone/>
                       </a:pPr>
                       <a:r>
-                        <a:rPr lang="en-US" altLang="zh-MO" sz="1100" b="0" i="0" u="none" strike="noStrike" kern="1200">
+                        <a:rPr lang="en-US" sz="1100" b="0" i="0" u="none" strike="noStrike" kern="1200" dirty="0">
                           <a:solidFill>
                             <a:srgbClr val="000000"/>
                           </a:solidFill>
@@ -10273,7 +10249,7 @@
                         <a:buNone/>
                       </a:pPr>
                       <a:r>
-                        <a:rPr lang="zh-MO" sz="1100" b="0" i="0" u="none" strike="noStrike">
+                        <a:rPr lang="en-US" sz="1100" b="0" i="0" u="none" strike="noStrike">
                           <a:solidFill>
                             <a:srgbClr val="000000"/>
                           </a:solidFill>
@@ -10471,7 +10447,7 @@
                         <a:buNone/>
                       </a:pPr>
                       <a:r>
-                        <a:rPr lang="en-US" altLang="zh-MO" sz="1100" b="0" i="0" u="none" strike="noStrike" kern="1200" dirty="0">
+                        <a:rPr lang="en-US" sz="1100" b="0" i="0" u="none" strike="noStrike" kern="1200" dirty="0">
                           <a:solidFill>
                             <a:srgbClr val="000000"/>
                           </a:solidFill>
@@ -10532,7 +10508,7 @@
                         <a:buNone/>
                       </a:pPr>
                       <a:r>
-                        <a:rPr lang="en-US" altLang="zh-MO" sz="1100" b="0" i="0" u="none" strike="noStrike" kern="1200">
+                        <a:rPr lang="en-US" sz="1100" b="0" i="0" u="none" strike="noStrike" kern="1200" dirty="0">
                           <a:solidFill>
                             <a:srgbClr val="000000"/>
                           </a:solidFill>
@@ -10600,7 +10576,7 @@
                         <a:buNone/>
                       </a:pPr>
                       <a:r>
-                        <a:rPr lang="en-US" altLang="zh-MO" sz="1100" b="0" i="0" u="none" strike="noStrike" kern="1200" dirty="0">
+                        <a:rPr lang="en-US" sz="1100" b="0" i="0" u="none" strike="noStrike" kern="1200" dirty="0">
                           <a:solidFill>
                             <a:srgbClr val="000000"/>
                           </a:solidFill>
@@ -10661,7 +10637,7 @@
                         <a:buNone/>
                       </a:pPr>
                       <a:r>
-                        <a:rPr lang="en-US" altLang="zh-MO" sz="1100" b="0" i="0" u="none" strike="noStrike" kern="1200">
+                        <a:rPr lang="en-US" sz="1100" b="0" i="0" u="none" strike="noStrike" kern="1200" dirty="0">
                           <a:solidFill>
                             <a:srgbClr val="000000"/>
                           </a:solidFill>
@@ -10928,7 +10904,7 @@
                         <a:buNone/>
                       </a:pPr>
                       <a:r>
-                        <a:rPr lang="en-US" altLang="zh-MO" sz="1100" b="0" i="0" u="none" strike="noStrike" kern="1200">
+                        <a:rPr lang="en-US" sz="1100" b="0" i="0" u="none" strike="noStrike" kern="1200" dirty="0">
                           <a:solidFill>
                             <a:srgbClr val="000000"/>
                           </a:solidFill>
@@ -10989,7 +10965,7 @@
                         <a:buNone/>
                       </a:pPr>
                       <a:r>
-                        <a:rPr lang="en-US" altLang="zh-MO" sz="1100" b="0" i="0" u="none" strike="noStrike" kern="1200">
+                        <a:rPr lang="en-US" sz="1100" b="0" i="0" u="none" strike="noStrike" kern="1200" dirty="0">
                           <a:solidFill>
                             <a:srgbClr val="000000"/>
                           </a:solidFill>
@@ -11057,7 +11033,7 @@
                         <a:buNone/>
                       </a:pPr>
                       <a:r>
-                        <a:rPr lang="en-US" altLang="zh-MO" sz="1100" b="0" i="0" u="none" strike="noStrike" kern="1200">
+                        <a:rPr lang="en-US" sz="1100" b="0" i="0" u="none" strike="noStrike" kern="1200" dirty="0">
                           <a:solidFill>
                             <a:srgbClr val="000000"/>
                           </a:solidFill>
@@ -11118,7 +11094,7 @@
                         <a:buNone/>
                       </a:pPr>
                       <a:r>
-                        <a:rPr lang="en-US" altLang="zh-MO" sz="1100" b="0" i="0" u="none" strike="noStrike" kern="1200">
+                        <a:rPr lang="en-US" sz="1100" b="0" i="0" u="none" strike="noStrike" kern="1200" dirty="0">
                           <a:solidFill>
                             <a:srgbClr val="000000"/>
                           </a:solidFill>
@@ -11385,7 +11361,7 @@
                         <a:buNone/>
                       </a:pPr>
                       <a:r>
-                        <a:rPr lang="en-US" altLang="zh-MO" sz="1100" b="0" i="0" u="none" strike="noStrike" kern="1200" dirty="0">
+                        <a:rPr lang="en-US" sz="1100" b="0" i="0" u="none" strike="noStrike" kern="1200" dirty="0">
                           <a:solidFill>
                             <a:srgbClr val="000000"/>
                           </a:solidFill>
@@ -11446,7 +11422,7 @@
                         <a:buNone/>
                       </a:pPr>
                       <a:r>
-                        <a:rPr lang="en-US" altLang="zh-MO" sz="1100" b="0" i="0" u="none" strike="noStrike" kern="1200">
+                        <a:rPr lang="en-US" sz="1100" b="0" i="0" u="none" strike="noStrike" kern="1200" dirty="0">
                           <a:solidFill>
                             <a:srgbClr val="000000"/>
                           </a:solidFill>
@@ -11514,7 +11490,7 @@
                         <a:buNone/>
                       </a:pPr>
                       <a:r>
-                        <a:rPr lang="en-US" altLang="zh-MO" sz="1100" b="0" i="0" u="none" strike="noStrike" kern="1200" dirty="0">
+                        <a:rPr lang="en-US" sz="1100" b="0" i="0" u="none" strike="noStrike" kern="1200" dirty="0">
                           <a:solidFill>
                             <a:srgbClr val="000000"/>
                           </a:solidFill>
@@ -11575,7 +11551,7 @@
                         <a:buNone/>
                       </a:pPr>
                       <a:r>
-                        <a:rPr lang="en-US" altLang="zh-MO" sz="1100" b="0" i="0" u="none" strike="noStrike" kern="1200">
+                        <a:rPr lang="en-US" sz="1100" b="0" i="0" u="none" strike="noStrike" kern="1200" dirty="0">
                           <a:solidFill>
                             <a:srgbClr val="000000"/>
                           </a:solidFill>
@@ -11842,7 +11818,7 @@
                         <a:buNone/>
                       </a:pPr>
                       <a:r>
-                        <a:rPr lang="en-US" altLang="zh-MO" sz="1100" b="0" i="0" u="none" strike="noStrike" kern="1200">
+                        <a:rPr lang="en-US" sz="1100" b="0" i="0" u="none" strike="noStrike" kern="1200" dirty="0">
                           <a:solidFill>
                             <a:srgbClr val="000000"/>
                           </a:solidFill>
@@ -11903,7 +11879,7 @@
                         <a:buNone/>
                       </a:pPr>
                       <a:r>
-                        <a:rPr lang="en-US" altLang="zh-MO" sz="1100" b="0" i="0" u="none" strike="noStrike" kern="1200">
+                        <a:rPr lang="en-US" sz="1100" b="0" i="0" u="none" strike="noStrike" kern="1200" dirty="0">
                           <a:solidFill>
                             <a:srgbClr val="000000"/>
                           </a:solidFill>
@@ -11971,7 +11947,7 @@
                         <a:buNone/>
                       </a:pPr>
                       <a:r>
-                        <a:rPr lang="en-US" altLang="zh-MO" sz="1100" b="0" i="0" u="none" strike="noStrike" kern="1200" dirty="0">
+                        <a:rPr lang="en-US" sz="1100" b="0" i="0" u="none" strike="noStrike" kern="1200" dirty="0">
                           <a:solidFill>
                             <a:srgbClr val="000000"/>
                           </a:solidFill>
@@ -12032,7 +12008,7 @@
                         <a:buNone/>
                       </a:pPr>
                       <a:r>
-                        <a:rPr lang="en-US" altLang="zh-MO" sz="1100" b="0" i="0" u="none" strike="noStrike" kern="1200">
+                        <a:rPr lang="en-US" sz="1100" b="0" i="0" u="none" strike="noStrike" kern="1200" dirty="0">
                           <a:solidFill>
                             <a:srgbClr val="000000"/>
                           </a:solidFill>
@@ -12299,7 +12275,7 @@
                         <a:buNone/>
                       </a:pPr>
                       <a:r>
-                        <a:rPr lang="en-US" altLang="zh-MO" sz="1100" b="0" i="0" u="none" strike="noStrike" kern="1200">
+                        <a:rPr lang="en-US" sz="1100" b="0" i="0" u="none" strike="noStrike" kern="1200" dirty="0">
                           <a:solidFill>
                             <a:srgbClr val="000000"/>
                           </a:solidFill>
@@ -12360,7 +12336,7 @@
                         <a:buNone/>
                       </a:pPr>
                       <a:r>
-                        <a:rPr lang="en-US" altLang="zh-MO" sz="1100" b="0" i="0" u="none" strike="noStrike" kern="1200" dirty="0">
+                        <a:rPr lang="en-US" sz="1100" b="0" i="0" u="none" strike="noStrike" kern="1200" dirty="0">
                           <a:solidFill>
                             <a:srgbClr val="000000"/>
                           </a:solidFill>
@@ -12428,7 +12404,7 @@
                         <a:buNone/>
                       </a:pPr>
                       <a:r>
-                        <a:rPr lang="en-US" altLang="zh-MO" sz="1100" b="0" i="0" u="none" strike="noStrike" kern="1200" dirty="0">
+                        <a:rPr lang="en-US" sz="1100" b="0" i="0" u="none" strike="noStrike" kern="1200" dirty="0">
                           <a:solidFill>
                             <a:srgbClr val="000000"/>
                           </a:solidFill>
@@ -12489,7 +12465,7 @@
                         <a:buNone/>
                       </a:pPr>
                       <a:r>
-                        <a:rPr lang="en-US" altLang="zh-MO" sz="1100" b="0" i="0" u="none" strike="noStrike" kern="1200">
+                        <a:rPr lang="en-US" sz="1100" b="0" i="0" u="none" strike="noStrike" kern="1200" dirty="0">
                           <a:solidFill>
                             <a:srgbClr val="000000"/>
                           </a:solidFill>
@@ -12756,7 +12732,7 @@
                         <a:buNone/>
                       </a:pPr>
                       <a:r>
-                        <a:rPr lang="en-US" altLang="zh-MO" sz="1100" b="0" i="0" u="none" strike="noStrike" kern="1200">
+                        <a:rPr lang="en-US" sz="1100" b="0" i="0" u="none" strike="noStrike" kern="1200" dirty="0">
                           <a:solidFill>
                             <a:srgbClr val="000000"/>
                           </a:solidFill>
@@ -12817,7 +12793,7 @@
                         <a:buNone/>
                       </a:pPr>
                       <a:r>
-                        <a:rPr lang="en-US" altLang="zh-MO" sz="1100" b="0" i="0" u="none" strike="noStrike" kern="1200" dirty="0">
+                        <a:rPr lang="en-US" sz="1100" b="0" i="0" u="none" strike="noStrike" kern="1200" dirty="0">
                           <a:solidFill>
                             <a:srgbClr val="000000"/>
                           </a:solidFill>
@@ -12885,7 +12861,7 @@
                         <a:buNone/>
                       </a:pPr>
                       <a:r>
-                        <a:rPr lang="en-US" altLang="zh-MO" sz="1100" b="0" i="0" u="none" strike="noStrike" kern="1200">
+                        <a:rPr lang="en-US" sz="1100" b="0" i="0" u="none" strike="noStrike" kern="1200" dirty="0">
                           <a:solidFill>
                             <a:srgbClr val="000000"/>
                           </a:solidFill>
@@ -12946,7 +12922,7 @@
                         <a:buNone/>
                       </a:pPr>
                       <a:r>
-                        <a:rPr lang="en-US" altLang="zh-MO" sz="1100" b="0" i="0" u="none" strike="noStrike" kern="1200">
+                        <a:rPr lang="en-US" sz="1100" b="0" i="0" u="none" strike="noStrike" kern="1200" dirty="0">
                           <a:solidFill>
                             <a:srgbClr val="000000"/>
                           </a:solidFill>
@@ -13213,7 +13189,7 @@
                         <a:buNone/>
                       </a:pPr>
                       <a:r>
-                        <a:rPr lang="en-US" altLang="zh-MO" sz="1100" b="0" i="0" u="none" strike="noStrike" kern="1200">
+                        <a:rPr lang="en-US" sz="1100" b="0" i="0" u="none" strike="noStrike" kern="1200" dirty="0">
                           <a:solidFill>
                             <a:srgbClr val="000000"/>
                           </a:solidFill>
@@ -13274,7 +13250,7 @@
                         <a:buNone/>
                       </a:pPr>
                       <a:r>
-                        <a:rPr lang="en-US" altLang="zh-MO" sz="1100" b="0" i="0" u="none" strike="noStrike" kern="1200">
+                        <a:rPr lang="en-US" sz="1100" b="0" i="0" u="none" strike="noStrike" kern="1200" dirty="0">
                           <a:solidFill>
                             <a:srgbClr val="000000"/>
                           </a:solidFill>
@@ -13342,7 +13318,7 @@
                         <a:buNone/>
                       </a:pPr>
                       <a:r>
-                        <a:rPr lang="en-US" altLang="zh-MO" sz="1100" b="0" i="0" u="none" strike="noStrike" kern="1200">
+                        <a:rPr lang="en-US" sz="1100" b="0" i="0" u="none" strike="noStrike" kern="1200" dirty="0">
                           <a:solidFill>
                             <a:srgbClr val="000000"/>
                           </a:solidFill>
@@ -13403,7 +13379,7 @@
                         <a:buNone/>
                       </a:pPr>
                       <a:r>
-                        <a:rPr lang="en-US" altLang="zh-MO" sz="1100" b="0" i="0" u="none" strike="noStrike" kern="1200" dirty="0">
+                        <a:rPr lang="en-US" sz="1100" b="0" i="0" u="none" strike="noStrike" kern="1200" dirty="0">
                           <a:solidFill>
                             <a:srgbClr val="000000"/>
                           </a:solidFill>
@@ -13670,7 +13646,7 @@
                         <a:buNone/>
                       </a:pPr>
                       <a:r>
-                        <a:rPr lang="en-US" altLang="zh-MO" sz="1100" b="0" i="0" u="none" strike="noStrike" kern="1200">
+                        <a:rPr lang="en-US" sz="1100" b="0" i="0" u="none" strike="noStrike" kern="1200" dirty="0">
                           <a:solidFill>
                             <a:srgbClr val="000000"/>
                           </a:solidFill>
@@ -13731,7 +13707,7 @@
                         <a:buNone/>
                       </a:pPr>
                       <a:r>
-                        <a:rPr lang="en-US" altLang="zh-MO" sz="1100" b="0" i="0" u="none" strike="noStrike" kern="1200" dirty="0">
+                        <a:rPr lang="en-US" sz="1100" b="0" i="0" u="none" strike="noStrike" kern="1200" dirty="0">
                           <a:solidFill>
                             <a:srgbClr val="000000"/>
                           </a:solidFill>
@@ -13799,7 +13775,7 @@
                         <a:buNone/>
                       </a:pPr>
                       <a:r>
-                        <a:rPr lang="en-US" altLang="zh-MO" sz="1100" b="0" i="0" u="none" strike="noStrike" kern="1200" dirty="0">
+                        <a:rPr lang="en-US" sz="1100" b="0" i="0" u="none" strike="noStrike" kern="1200" dirty="0">
                           <a:solidFill>
                             <a:srgbClr val="000000"/>
                           </a:solidFill>
@@ -13809,18 +13785,6 @@
                           <a:cs typeface="+mn-cs"/>
                         </a:rPr>
                         <a:t>@@D24C0@@</a:t>
-                      </a:r>
-                      <a:r>
-                        <a:rPr lang="zh-MO" altLang="en-US" sz="1100" b="0" i="0" u="none" strike="noStrike" kern="1200" dirty="0">
-                          <a:solidFill>
-                            <a:srgbClr val="000000"/>
-                          </a:solidFill>
-                          <a:effectLst/>
-                          <a:latin typeface="Abadi" panose="020F0502020204030204" pitchFamily="34" charset="0"/>
-                          <a:ea typeface="+mn-ea"/>
-                          <a:cs typeface="+mn-cs"/>
-                        </a:rPr>
-                        <a:t/>
                       </a:r>
                     </a:p>
                   </a:txBody>
@@ -14218,7 +14182,7 @@
                         <a:buNone/>
                       </a:pPr>
                       <a:r>
-                        <a:rPr lang="zh-MO" altLang="en-US" sz="1100" b="0" i="0" u="none" strike="noStrike" kern="1200" dirty="0">
+                        <a:rPr lang="en-US" sz="1100" b="0" i="0" u="none" strike="noStrike" kern="1200" dirty="0">
                           <a:solidFill>
                             <a:srgbClr val="000000"/>
                           </a:solidFill>
@@ -14286,7 +14250,7 @@
                         <a:buNone/>
                       </a:pPr>
                       <a:r>
-                        <a:rPr lang="en-US" altLang="zh-MO" sz="1100" b="0" i="0" u="none" strike="noStrike" kern="1200" dirty="0">
+                        <a:rPr lang="en-US" sz="1100" b="0" i="0" u="none" strike="noStrike" kern="1200" dirty="0">
                           <a:solidFill>
                             <a:srgbClr val="000000"/>
                           </a:solidFill>
@@ -14296,18 +14260,6 @@
                           <a:cs typeface="+mn-cs"/>
                         </a:rPr>
                         <a:t>@@D25C0@@</a:t>
-                      </a:r>
-                      <a:r>
-                        <a:rPr lang="zh-MO" altLang="en-US" sz="1100" b="0" i="0" u="none" strike="noStrike" kern="1200" dirty="0">
-                          <a:solidFill>
-                            <a:srgbClr val="000000"/>
-                          </a:solidFill>
-                          <a:effectLst/>
-                          <a:latin typeface="Abadi" panose="020F0502020204030204" pitchFamily="34" charset="0"/>
-                          <a:ea typeface="+mn-ea"/>
-                          <a:cs typeface="+mn-cs"/>
-                        </a:rPr>
-                        <a:t/>
                       </a:r>
                     </a:p>
                   </a:txBody>
@@ -14705,7 +14657,7 @@
                         <a:buNone/>
                       </a:pPr>
                       <a:r>
-                        <a:rPr lang="zh-MO" altLang="en-US" sz="1100" b="0" i="0" u="none" strike="noStrike" kern="1200" dirty="0">
+                        <a:rPr lang="en-US" sz="1100" b="0" i="0" u="none" strike="noStrike" kern="1200" dirty="0">
                           <a:solidFill>
                             <a:srgbClr val="000000"/>
                           </a:solidFill>
@@ -14773,7 +14725,7 @@
                         <a:buNone/>
                       </a:pPr>
                       <a:r>
-                        <a:rPr lang="en-US" altLang="zh-MO" sz="1100" b="0" i="0" u="none" strike="noStrike" kern="1200">
+                        <a:rPr lang="en-US" sz="1100" b="0" i="0" u="none" strike="noStrike" kern="1200" dirty="0">
                           <a:solidFill>
                             <a:srgbClr val="000000"/>
                           </a:solidFill>
@@ -14834,7 +14786,7 @@
                         <a:buNone/>
                       </a:pPr>
                       <a:r>
-                        <a:rPr lang="en-US" altLang="zh-MO" sz="1100" b="0" i="0" u="none" strike="noStrike" kern="1200" dirty="0">
+                        <a:rPr lang="en-US" sz="1100" b="0" i="0" u="none" strike="noStrike" kern="1200" dirty="0">
                           <a:solidFill>
                             <a:srgbClr val="000000"/>
                           </a:solidFill>
@@ -14895,7 +14847,7 @@
                         <a:buNone/>
                       </a:pPr>
                       <a:r>
-                        <a:rPr lang="zh-MO" sz="1100" b="0" i="0" u="none" strike="noStrike">
+                        <a:rPr lang="en-US" sz="1100" b="0" i="0" u="none" strike="noStrike">
                           <a:solidFill>
                             <a:srgbClr val="000000"/>
                           </a:solidFill>
@@ -15093,7 +15045,7 @@
                         <a:buNone/>
                       </a:pPr>
                       <a:r>
-                        <a:rPr lang="en-US" altLang="zh-MO" sz="1100" b="0" i="0" u="none" strike="noStrike" kern="1200">
+                        <a:rPr lang="en-US" sz="1100" b="0" i="0" u="none" strike="noStrike" kern="1200" dirty="0">
                           <a:solidFill>
                             <a:srgbClr val="000000"/>
                           </a:solidFill>
@@ -15154,7 +15106,7 @@
                         <a:buNone/>
                       </a:pPr>
                       <a:r>
-                        <a:rPr lang="en-US" altLang="zh-MO" sz="1100" b="0" i="0" u="none" strike="noStrike" kern="1200">
+                        <a:rPr lang="en-US" sz="1100" b="0" i="0" u="none" strike="noStrike" kern="1200" dirty="0">
                           <a:solidFill>
                             <a:srgbClr val="000000"/>
                           </a:solidFill>
@@ -15222,7 +15174,7 @@
                         <a:buNone/>
                       </a:pPr>
                       <a:r>
-                        <a:rPr lang="en-US" altLang="zh-MO" sz="1100" b="0" i="0" u="none" strike="noStrike" kern="1200">
+                        <a:rPr lang="en-US" sz="1100" b="0" i="0" u="none" strike="noStrike" kern="1200" dirty="0">
                           <a:solidFill>
                             <a:srgbClr val="000000"/>
                           </a:solidFill>
@@ -15283,7 +15235,7 @@
                         <a:buNone/>
                       </a:pPr>
                       <a:r>
-                        <a:rPr lang="en-US" altLang="zh-MO" sz="1100" b="0" i="0" u="none" strike="noStrike" kern="1200">
+                        <a:rPr lang="en-US" sz="1100" b="0" i="0" u="none" strike="noStrike" kern="1200" dirty="0">
                           <a:solidFill>
                             <a:srgbClr val="000000"/>
                           </a:solidFill>
@@ -15550,7 +15502,7 @@
                         <a:buNone/>
                       </a:pPr>
                       <a:r>
-                        <a:rPr lang="en-US" altLang="zh-MO" sz="1100" b="0" i="0" u="none" strike="noStrike" kern="1200">
+                        <a:rPr lang="en-US" sz="1100" b="0" i="0" u="none" strike="noStrike" kern="1200" dirty="0">
                           <a:solidFill>
                             <a:srgbClr val="000000"/>
                           </a:solidFill>
@@ -15611,7 +15563,7 @@
                         <a:buNone/>
                       </a:pPr>
                       <a:r>
-                        <a:rPr lang="en-US" altLang="zh-MO" sz="1100" b="0" i="0" u="none" strike="noStrike" kern="1200" dirty="0">
+                        <a:rPr lang="en-US" sz="1100" b="0" i="0" u="none" strike="noStrike" kern="1200" dirty="0">
                           <a:solidFill>
                             <a:srgbClr val="000000"/>
                           </a:solidFill>
@@ -15679,7 +15631,7 @@
                         <a:buNone/>
                       </a:pPr>
                       <a:r>
-                        <a:rPr lang="en-US" altLang="zh-MO" sz="1100" b="0" i="0" u="none" strike="noStrike" kern="1200">
+                        <a:rPr lang="en-US" sz="1100" b="0" i="0" u="none" strike="noStrike" kern="1200" dirty="0">
                           <a:solidFill>
                             <a:srgbClr val="000000"/>
                           </a:solidFill>
@@ -15740,7 +15692,7 @@
                         <a:buNone/>
                       </a:pPr>
                       <a:r>
-                        <a:rPr lang="en-US" altLang="zh-MO" sz="1100" b="0" i="0" u="none" strike="noStrike" kern="1200">
+                        <a:rPr lang="en-US" sz="1100" b="0" i="0" u="none" strike="noStrike" kern="1200" dirty="0">
                           <a:solidFill>
                             <a:srgbClr val="000000"/>
                           </a:solidFill>
@@ -16007,7 +15959,7 @@
                         <a:buNone/>
                       </a:pPr>
                       <a:r>
-                        <a:rPr lang="en-US" altLang="zh-MO" sz="1100" b="0" i="0" u="none" strike="noStrike" kern="1200">
+                        <a:rPr lang="en-US" sz="1100" b="0" i="0" u="none" strike="noStrike" kern="1200" dirty="0">
                           <a:solidFill>
                             <a:srgbClr val="000000"/>
                           </a:solidFill>
@@ -16068,7 +16020,7 @@
                         <a:buNone/>
                       </a:pPr>
                       <a:r>
-                        <a:rPr lang="en-US" altLang="zh-MO" sz="1100" b="0" i="0" u="none" strike="noStrike" kern="1200" dirty="0">
+                        <a:rPr lang="en-US" sz="1100" b="0" i="0" u="none" strike="noStrike" kern="1200" dirty="0">
                           <a:solidFill>
                             <a:srgbClr val="000000"/>
                           </a:solidFill>
@@ -16136,7 +16088,7 @@
                         <a:buNone/>
                       </a:pPr>
                       <a:r>
-                        <a:rPr lang="en-US" altLang="zh-MO" sz="1100" b="0" i="0" u="none" strike="noStrike" kern="1200">
+                        <a:rPr lang="en-US" sz="1100" b="0" i="0" u="none" strike="noStrike" kern="1200" dirty="0">
                           <a:solidFill>
                             <a:srgbClr val="000000"/>
                           </a:solidFill>
@@ -16197,7 +16149,7 @@
                         <a:buNone/>
                       </a:pPr>
                       <a:r>
-                        <a:rPr lang="en-US" altLang="zh-MO" sz="1100" b="0" i="0" u="none" strike="noStrike" kern="1200" dirty="0">
+                        <a:rPr lang="en-US" sz="1100" b="0" i="0" u="none" strike="noStrike" kern="1200" dirty="0">
                           <a:solidFill>
                             <a:srgbClr val="000000"/>
                           </a:solidFill>
@@ -16464,7 +16416,7 @@
                         <a:buNone/>
                       </a:pPr>
                       <a:r>
-                        <a:rPr lang="en-US" altLang="zh-MO" sz="1100" b="0" i="0" u="none" strike="noStrike" kern="1200">
+                        <a:rPr lang="en-US" sz="1100" b="0" i="0" u="none" strike="noStrike" kern="1200" dirty="0">
                           <a:solidFill>
                             <a:srgbClr val="000000"/>
                           </a:solidFill>
@@ -16525,7 +16477,7 @@
                         <a:buNone/>
                       </a:pPr>
                       <a:r>
-                        <a:rPr lang="en-US" altLang="zh-MO" sz="1100" b="0" i="0" u="none" strike="noStrike" kern="1200" dirty="0">
+                        <a:rPr lang="en-US" sz="1100" b="0" i="0" u="none" strike="noStrike" kern="1200" dirty="0">
                           <a:solidFill>
                             <a:srgbClr val="000000"/>
                           </a:solidFill>
@@ -16593,7 +16545,7 @@
                         <a:buNone/>
                       </a:pPr>
                       <a:r>
-                        <a:rPr lang="en-US" altLang="zh-MO" sz="1100" b="0" i="0" u="none" strike="noStrike" kern="1200">
+                        <a:rPr lang="en-US" sz="1100" b="0" i="0" u="none" strike="noStrike" kern="1200" dirty="0">
                           <a:solidFill>
                             <a:srgbClr val="000000"/>
                           </a:solidFill>
@@ -16654,7 +16606,7 @@
                         <a:buNone/>
                       </a:pPr>
                       <a:r>
-                        <a:rPr lang="en-US" altLang="zh-MO" sz="1100" b="0" i="0" u="none" strike="noStrike" kern="1200" dirty="0">
+                        <a:rPr lang="en-US" sz="1100" b="0" i="0" u="none" strike="noStrike" kern="1200" dirty="0">
                           <a:solidFill>
                             <a:srgbClr val="000000"/>
                           </a:solidFill>
@@ -16921,7 +16873,7 @@
                         <a:buNone/>
                       </a:pPr>
                       <a:r>
-                        <a:rPr lang="en-US" altLang="zh-MO" sz="1100" b="0" i="0" u="none" strike="noStrike" kern="1200">
+                        <a:rPr lang="en-US" sz="1100" b="0" i="0" u="none" strike="noStrike" kern="1200" dirty="0">
                           <a:solidFill>
                             <a:srgbClr val="000000"/>
                           </a:solidFill>
@@ -16982,7 +16934,7 @@
                         <a:buNone/>
                       </a:pPr>
                       <a:r>
-                        <a:rPr lang="en-US" altLang="zh-MO" sz="1100" b="0" i="0" u="none" strike="noStrike" kern="1200" dirty="0">
+                        <a:rPr lang="en-US" sz="1100" b="0" i="0" u="none" strike="noStrike" kern="1200" dirty="0">
                           <a:solidFill>
                             <a:srgbClr val="000000"/>
                           </a:solidFill>
@@ -17050,7 +17002,7 @@
                         <a:buNone/>
                       </a:pPr>
                       <a:r>
-                        <a:rPr lang="en-US" altLang="zh-MO" sz="1100" b="0" i="0" u="none" strike="noStrike" kern="1200">
+                        <a:rPr lang="en-US" sz="1100" b="0" i="0" u="none" strike="noStrike" kern="1200" dirty="0">
                           <a:solidFill>
                             <a:srgbClr val="000000"/>
                           </a:solidFill>
@@ -17111,7 +17063,7 @@
                         <a:buNone/>
                       </a:pPr>
                       <a:r>
-                        <a:rPr lang="en-US" altLang="zh-MO" sz="1100" b="0" i="0" u="none" strike="noStrike" kern="1200" dirty="0">
+                        <a:rPr lang="en-US" sz="1100" b="0" i="0" u="none" strike="noStrike" kern="1200" dirty="0">
                           <a:solidFill>
                             <a:srgbClr val="000000"/>
                           </a:solidFill>
@@ -17172,12 +17124,12 @@
                         <a:buNone/>
                       </a:pPr>
                       <a:r>
-                        <a:rPr lang="zh-MO" sz="1100" b="0" i="0" u="none" strike="noStrike">
-                          <a:solidFill>
-                            <a:srgbClr val="000000"/>
-                          </a:solidFill>
-                          <a:effectLst/>
-                          <a:latin typeface="新細明體" panose="02020500000000000000" pitchFamily="18" charset="-120"/>
+                        <a:rPr lang="en-US" sz="1100" b="0" i="0" u="none" strike="noStrike">
+                          <a:solidFill>
+                            <a:srgbClr val="000000"/>
+                          </a:solidFill>
+                          <a:effectLst/>
+                          <a:latin typeface="Wingdings" panose="05000000000000000000" pitchFamily="2" charset="2"/>
                           <a:ea typeface="新細明體" panose="02020500000000000000" pitchFamily="18" charset="-120"/>
                         </a:rPr>
                         <a:t>@@D31C2@@</a:t>
@@ -17232,13 +17184,14 @@
                         <a:buNone/>
                       </a:pPr>
                       <a:r>
-                        <a:rPr lang="zh-MO" sz="1100" b="0" i="0" u="none" strike="noStrike">
-                          <a:solidFill>
-                            <a:srgbClr val="000000"/>
-                          </a:solidFill>
-                          <a:effectLst/>
-                          <a:latin typeface="新細明體" panose="02020500000000000000" pitchFamily="18" charset="-120"/>
-                          <a:ea typeface="新細明體" panose="02020500000000000000" pitchFamily="18" charset="-120"/>
+                        <a:rPr lang="en-US" sz="1100" b="0" i="0" u="none" strike="noStrike" kern="1200" dirty="0">
+                          <a:solidFill>
+                            <a:srgbClr val="000000"/>
+                          </a:solidFill>
+                          <a:effectLst/>
+                          <a:latin typeface="Abadi" panose="020F0502020204030204" pitchFamily="34" charset="0"/>
+                          <a:ea typeface="+mn-ea"/>
+                          <a:cs typeface="+mn-cs"/>
                         </a:rPr>
                         <a:t>@@D31C3@@</a:t>
                       </a:r>
@@ -17292,13 +17245,14 @@
                         <a:buNone/>
                       </a:pPr>
                       <a:r>
-                        <a:rPr lang="zh-MO" sz="1100" b="0" i="0" u="none" strike="noStrike">
-                          <a:solidFill>
-                            <a:srgbClr val="000000"/>
-                          </a:solidFill>
-                          <a:effectLst/>
-                          <a:latin typeface="新細明體" panose="02020500000000000000" pitchFamily="18" charset="-120"/>
-                          <a:ea typeface="新細明體" panose="02020500000000000000" pitchFamily="18" charset="-120"/>
+                        <a:rPr lang="en-US" sz="1100" b="0" i="0" u="none" strike="noStrike" kern="1200" dirty="0">
+                          <a:solidFill>
+                            <a:srgbClr val="000000"/>
+                          </a:solidFill>
+                          <a:effectLst/>
+                          <a:latin typeface="Abadi" panose="020F0502020204030204" pitchFamily="34" charset="0"/>
+                          <a:ea typeface="+mn-ea"/>
+                          <a:cs typeface="+mn-cs"/>
                         </a:rPr>
                         <a:t>@@D31C4@@</a:t>
                       </a:r>
@@ -17352,7 +17306,7 @@
                         <a:buNone/>
                       </a:pPr>
                       <a:r>
-                        <a:rPr lang="en-US" altLang="zh-MO" sz="1100" b="0" i="0" u="none" strike="noStrike" kern="1200">
+                        <a:rPr lang="en-US" sz="1100" b="0" i="0" u="none" strike="noStrike" kern="1200" dirty="0">
                           <a:solidFill>
                             <a:srgbClr val="000000"/>
                           </a:solidFill>
@@ -17413,7 +17367,7 @@
                         <a:buNone/>
                       </a:pPr>
                       <a:r>
-                        <a:rPr lang="en-US" altLang="zh-MO" sz="1100" b="0" i="0" u="none" strike="noStrike" kern="1200" dirty="0">
+                        <a:rPr lang="en-US" sz="1100" b="0" i="0" u="none" strike="noStrike" kern="1200" dirty="0">
                           <a:solidFill>
                             <a:srgbClr val="000000"/>
                           </a:solidFill>

</xml_diff>